<commit_message>
Check structural invariants on every deck the tests save
python-pptx and LibreOffice open files PowerPoint would repair. The new
checks cover what PowerPoint is strict about: dangling r:ids and
relationship targets, missing content types, duplicate shape and series
ids, table spans, element order in p:sp, and section/slide order.

The fixture had negative chart axis ids from python-pptx, which the
schema does not allow; the generator now fixes them.
</commit_message>
<xml_diff>
--- a/tests/fixtures/template.pptx
+++ b/tests/fixtures/template.pptx
@@ -277,11 +277,11 @@
             </c:numRef>
           </c:val>
         </c:ser>
-        <c:axId val="-2068027336"/>
-        <c:axId val="-2113994440"/>
+        <c:axId val="2068027336"/>
+        <c:axId val="2113994440"/>
       </c:barChart>
       <c:catAx>
-        <c:axId val="-2068027336"/>
+        <c:axId val="2068027336"/>
         <c:scaling>
           <c:orientation val="minMax"/>
         </c:scaling>
@@ -290,7 +290,7 @@
         <c:majorTickMark val="out"/>
         <c:minorTickMark val="none"/>
         <c:tickLblPos val="nextTo"/>
-        <c:crossAx val="-2113994440"/>
+        <c:crossAx val="2113994440"/>
         <c:crosses val="autoZero"/>
         <c:auto val="1"/>
         <c:lblAlgn val="ctr"/>
@@ -298,7 +298,7 @@
         <c:noMultiLvlLbl val="0"/>
       </c:catAx>
       <c:valAx>
-        <c:axId val="-2113994440"/>
+        <c:axId val="2113994440"/>
         <c:scaling/>
         <c:delete val="0"/>
         <c:axPos val="l"/>
@@ -306,7 +306,7 @@
         <c:majorTickMark val="out"/>
         <c:minorTickMark val="none"/>
         <c:tickLblPos val="nextTo"/>
-        <c:crossAx val="-2068027336"/>
+        <c:crossAx val="2068027336"/>
         <c:crosses val="autoZero"/>
       </c:valAx>
     </c:plotArea>
@@ -592,11 +592,11 @@
           </c:yVal>
           <c:smooth val="0"/>
         </c:ser>
-        <c:axId val="-2128940872"/>
-        <c:axId val="-2129643912"/>
+        <c:axId val="2128940872"/>
+        <c:axId val="2129643912"/>
       </c:scatterChart>
       <c:valAx>
-        <c:axId val="-2128940872"/>
+        <c:axId val="2128940872"/>
         <c:scaling>
           <c:orientation val="minMax"/>
         </c:scaling>
@@ -606,12 +606,12 @@
         <c:majorTickMark val="out"/>
         <c:minorTickMark val="none"/>
         <c:tickLblPos val="nextTo"/>
-        <c:crossAx val="-2129643912"/>
+        <c:crossAx val="2129643912"/>
         <c:crosses val="autoZero"/>
         <c:crossBetween val="midCat"/>
       </c:valAx>
       <c:valAx>
-        <c:axId val="-2129643912"/>
+        <c:axId val="2129643912"/>
         <c:scaling>
           <c:orientation val="minMax"/>
         </c:scaling>
@@ -622,7 +622,7 @@
         <c:majorTickMark val="out"/>
         <c:minorTickMark val="none"/>
         <c:tickLblPos val="nextTo"/>
-        <c:crossAx val="-2128940872"/>
+        <c:crossAx val="2128940872"/>
         <c:crosses val="autoZero"/>
         <c:crossBetween val="midCat"/>
       </c:valAx>
@@ -732,11 +732,11 @@
         </c:dLbls>
         <c:bubbleScale val="100"/>
         <c:showNegBubbles val="0"/>
-        <c:axId val="-2115720072"/>
-        <c:axId val="-2115723560"/>
+        <c:axId val="2115720072"/>
+        <c:axId val="2115723560"/>
       </c:bubbleChart>
       <c:valAx>
-        <c:axId val="-2115720072"/>
+        <c:axId val="2115720072"/>
         <c:scaling>
           <c:orientation val="minMax"/>
         </c:scaling>
@@ -746,12 +746,12 @@
         <c:majorTickMark val="out"/>
         <c:minorTickMark val="none"/>
         <c:tickLblPos val="nextTo"/>
-        <c:crossAx val="-2115723560"/>
+        <c:crossAx val="2115723560"/>
         <c:crosses val="autoZero"/>
         <c:crossBetween val="midCat"/>
       </c:valAx>
       <c:valAx>
-        <c:axId val="-2115723560"/>
+        <c:axId val="2115723560"/>
         <c:scaling>
           <c:orientation val="minMax"/>
         </c:scaling>
@@ -762,7 +762,7 @@
         <c:majorTickMark val="out"/>
         <c:minorTickMark val="none"/>
         <c:tickLblPos val="nextTo"/>
-        <c:crossAx val="-2115720072"/>
+        <c:crossAx val="2115720072"/>
         <c:crosses val="autoZero"/>
         <c:crossBetween val="midCat"/>
       </c:valAx>

</xml_diff>